<commit_message>
feat: implement Phase 1-5 engineering audit + hardening (idempotent chat, cursor pagination, photo thumbnails, voice messaging, Realtime reconnect recovery)
Phases covered:
- Audit + risk report (typecheck clean, lint clean, 82 tests green)
- Chat: idempotency_key + guard_message_immutable trigger, cursor-based pagination with scroll-up recovery
- Photo pipeline: EXIF-stripping WebP processing, 480px thumbnails, 12MB bucket
- Voice: 5-min/5MB limits, 32kbps bitrate, signed upload + progress + abort + retry, orphan cleanup
- Realtime: member-gated channels, sanitizeRealtimeMessage, lastReceivedRef recovery

Co-Authored-By: Solar Mini4 <support@upstage.ai>
</commit_message>
<xml_diff>
--- a/docs/OUSTIANS_TECHNICAL_REPORT_DECK.pptx
+++ b/docs/OUSTIANS_TECHNICAL_REPORT_DECK.pptx
@@ -261,21 +261,8 @@
             </c:numRef>
           </c:val>
         </c:ser>
-        <c:dLbls>
-          <c:dLblPos val="outEnd"/>
-          <c:showLegendKey val="0"/>
-          <c:showVal val="1"/>
-          <c:showCatName val="1"/>
-          <c:showSerName val="0"/>
-          <c:showPercent val="1"/>
-          <c:showBubbleSize val="0"/>
-          <c:showLeaderLines val="1"/>
-        </c:dLbls>
       </c:pieChart>
     </c:plotArea>
-    <c:legend>
-      <c:legendPos val="b"/>
-    </c:legend>
     <c:dispBlanksAs val="gap"/>
   </c:chart>
   <c:txPr>
@@ -8425,8 +8412,8 @@
         </p:nvSpPr>
         <p:spPr>
           <a:xfrm>
-            <a:off x="548640" y="777240"/>
-            <a:ext cx="11064240" cy="457200"/>
+            <a:off x="548640" y="841248"/>
+            <a:ext cx="11064240" cy="640080"/>
           </a:xfrm>
           <a:prstGeom prst="rect">
             <a:avLst/>
@@ -8459,8 +8446,8 @@
           <p:nvPr/>
         </p:nvGraphicFramePr>
         <p:xfrm>
-          <a:off x="548640" y="1554480"/>
-          <a:ext cx="5120640" cy="3840480"/>
+          <a:off x="548640" y="1417320"/>
+          <a:ext cx="5303520" cy="4160520"/>
         </p:xfrm>
         <a:graphic>
           <a:graphicData uri="http://schemas.openxmlformats.org/drawingml/2006/chart">
@@ -8470,14 +8457,14 @@
       </p:graphicFrame>
       <p:sp>
         <p:nvSpPr>
-          <p:cNvPr id="5" name="TextBox 4"/>
+          <p:cNvPr id="6" name="TextBox 5"/>
           <p:cNvSpPr txBox="1"/>
           <p:nvPr/>
         </p:nvSpPr>
         <p:spPr>
           <a:xfrm>
-            <a:off x="6217920" y="1554480"/>
-            <a:ext cx="5394960" cy="3840480"/>
+            <a:off x="548640" y="6217920"/>
+            <a:ext cx="11064240" cy="365760"/>
           </a:xfrm>
           <a:prstGeom prst="rect">
             <a:avLst/>
@@ -8493,120 +8480,6 @@
           <a:p>
             <a:pPr>
               <a:spcAft>
-                <a:spcPts val="300"/>
-              </a:spcAft>
-            </a:pPr>
-            <a:r>
-              <a:rPr sz="1100">
-                <a:solidFill>
-                  <a:srgbClr val="11242B"/>
-                </a:solidFill>
-              </a:rPr>
-              <a:t>•  TSX 9,904 (40.8%) — routes, components, client islands</a:t>
-            </a:r>
-          </a:p>
-          <a:p>
-            <a:pPr>
-              <a:spcAft>
-                <a:spcPts val="300"/>
-              </a:spcAft>
-            </a:pPr>
-            <a:r>
-              <a:rPr sz="1100">
-                <a:solidFill>
-                  <a:srgbClr val="11242B"/>
-                </a:solidFill>
-              </a:rPr>
-              <a:t>•  TS 8,509 (35.0%) — Server Actions, queries, guards, Supabase clients</a:t>
-            </a:r>
-          </a:p>
-          <a:p>
-            <a:pPr>
-              <a:spcAft>
-                <a:spcPts val="300"/>
-              </a:spcAft>
-            </a:pPr>
-            <a:r>
-              <a:rPr sz="1100">
-                <a:solidFill>
-                  <a:srgbClr val="11242B"/>
-                </a:solidFill>
-              </a:rPr>
-              <a:t>•  SQL 3,971 (16.4%) — 16 migrations, ~62 RLS policies, ~40 RPCs</a:t>
-            </a:r>
-          </a:p>
-          <a:p>
-            <a:pPr>
-              <a:spcAft>
-                <a:spcPts val="300"/>
-              </a:spcAft>
-            </a:pPr>
-            <a:r>
-              <a:rPr sz="1100">
-                <a:solidFill>
-                  <a:srgbClr val="11242B"/>
-                </a:solidFill>
-              </a:rPr>
-              <a:t>•  JSON 1,068 (4.4%) — EN/AR catalogues ~534 lines each</a:t>
-            </a:r>
-          </a:p>
-          <a:p>
-            <a:pPr>
-              <a:spcAft>
-                <a:spcPts val="300"/>
-              </a:spcAft>
-            </a:pPr>
-            <a:r>
-              <a:rPr sz="1100">
-                <a:solidFill>
-                  <a:srgbClr val="11242B"/>
-                </a:solidFill>
-              </a:rPr>
-              <a:t>•  JS 554 (2.3%) — admin scripts, e2e, configs</a:t>
-            </a:r>
-          </a:p>
-          <a:p>
-            <a:pPr>
-              <a:spcAft>
-                <a:spcPts val="300"/>
-              </a:spcAft>
-            </a:pPr>
-            <a:r>
-              <a:rPr sz="1100">
-                <a:solidFill>
-                  <a:srgbClr val="11242B"/>
-                </a:solidFill>
-              </a:rPr>
-              <a:t>•  CSS 276 (1.1%) — tokens + Tailwind v4 theme (globals.css)</a:t>
-            </a:r>
-          </a:p>
-        </p:txBody>
-      </p:sp>
-      <p:sp>
-        <p:nvSpPr>
-          <p:cNvPr id="6" name="TextBox 5"/>
-          <p:cNvSpPr txBox="1"/>
-          <p:nvPr/>
-        </p:nvSpPr>
-        <p:spPr>
-          <a:xfrm>
-            <a:off x="548640" y="6400800"/>
-            <a:ext cx="11064240" cy="365760"/>
-          </a:xfrm>
-          <a:prstGeom prst="rect">
-            <a:avLst/>
-          </a:prstGeom>
-          <a:noFill/>
-        </p:spPr>
-        <p:txBody>
-          <a:bodyPr wrap="none">
-            <a:spAutoFit/>
-          </a:bodyPr>
-          <a:lstStyle/>
-          <a:p/>
-          <a:p>
-            <a:pPr>
-              <a:spcAft>
                 <a:spcPts val="400"/>
               </a:spcAft>
             </a:pPr>
@@ -8621,6 +8494,417 @@
           </a:p>
         </p:txBody>
       </p:sp>
+      <p:graphicFrame>
+        <p:nvGraphicFramePr>
+          <p:cNvPr id="7" name="Table 6"/>
+          <p:cNvGraphicFramePr>
+            <a:graphicFrameLocks noGrp="1"/>
+          </p:cNvGraphicFramePr>
+          <p:nvPr/>
+        </p:nvGraphicFramePr>
+        <p:xfrm>
+          <a:off x="6217920" y="1554480"/>
+          <a:ext cx="5394960" cy="3840480"/>
+        </p:xfrm>
+        <a:graphic>
+          <a:graphicData uri="http://schemas.openxmlformats.org/drawingml/2006/table">
+            <a:tbl>
+              <a:tblPr firstRow="0" bandRow="0" firstCol="0" lastRow="0" lastCol="0">
+                <a:tableStyleId>{2D5ABB26-0587-4C30-8999-92F81FD0307C}</a:tableStyleId>
+              </a:tblPr>
+              <a:tblGrid>
+                <a:gridCol w="237744"/>
+                <a:gridCol w="1572768"/>
+                <a:gridCol w="3584448"/>
+              </a:tblGrid>
+              <a:tr h="640080">
+                <a:tc>
+                  <a:txBody>
+                    <a:bodyPr wrap="square"/>
+                    <a:lstStyle/>
+                    <a:p>
+                      <a:r>
+                        <a:rPr sz="1100" b="0">
+                          <a:solidFill>
+                            <a:srgbClr val="11242B"/>
+                          </a:solidFill>
+                          <a:latin typeface="Calibri"/>
+                        </a:rPr>
+                        <a:t/>
+                      </a:r>
+                    </a:p>
+                  </a:txBody>
+                  <a:tcPr anchor="ctr" marL="18288" marR="18288" marT="54864" marB="54864">
+                    <a:solidFill>
+                      <a:srgbClr val="14495C"/>
+                    </a:solidFill>
+                  </a:tcPr>
+                </a:tc>
+                <a:tc>
+                  <a:txBody>
+                    <a:bodyPr wrap="square"/>
+                    <a:lstStyle/>
+                    <a:p>
+                      <a:r>
+                        <a:rPr sz="1100" b="1">
+                          <a:solidFill>
+                            <a:srgbClr val="11242B"/>
+                          </a:solidFill>
+                          <a:latin typeface="Calibri"/>
+                        </a:rPr>
+                        <a:t>TSX  9,904 (40.8%)</a:t>
+                      </a:r>
+                    </a:p>
+                  </a:txBody>
+                  <a:tcPr anchor="ctr" marL="91440" marR="36576" marT="54864" marB="54864">
+                    <a:noFill/>
+                  </a:tcPr>
+                </a:tc>
+                <a:tc>
+                  <a:txBody>
+                    <a:bodyPr wrap="square"/>
+                    <a:lstStyle/>
+                    <a:p>
+                      <a:r>
+                        <a:rPr sz="1100" b="0">
+                          <a:solidFill>
+                            <a:srgbClr val="5B6A72"/>
+                          </a:solidFill>
+                          <a:latin typeface="Calibri"/>
+                        </a:rPr>
+                        <a:t>routes, components, client islands</a:t>
+                      </a:r>
+                    </a:p>
+                  </a:txBody>
+                  <a:tcPr anchor="ctr" marL="54864" marR="36576" marT="54864" marB="54864">
+                    <a:noFill/>
+                  </a:tcPr>
+                </a:tc>
+              </a:tr>
+              <a:tr h="640080">
+                <a:tc>
+                  <a:txBody>
+                    <a:bodyPr wrap="square"/>
+                    <a:lstStyle/>
+                    <a:p>
+                      <a:r>
+                        <a:rPr sz="1100" b="0">
+                          <a:solidFill>
+                            <a:srgbClr val="11242B"/>
+                          </a:solidFill>
+                          <a:latin typeface="Calibri"/>
+                        </a:rPr>
+                        <a:t/>
+                      </a:r>
+                    </a:p>
+                  </a:txBody>
+                  <a:tcPr anchor="ctr" marL="18288" marR="18288" marT="54864" marB="54864">
+                    <a:solidFill>
+                      <a:srgbClr val="1B6076"/>
+                    </a:solidFill>
+                  </a:tcPr>
+                </a:tc>
+                <a:tc>
+                  <a:txBody>
+                    <a:bodyPr wrap="square"/>
+                    <a:lstStyle/>
+                    <a:p>
+                      <a:r>
+                        <a:rPr sz="1100" b="1">
+                          <a:solidFill>
+                            <a:srgbClr val="11242B"/>
+                          </a:solidFill>
+                          <a:latin typeface="Calibri"/>
+                        </a:rPr>
+                        <a:t>TS  8,509 (35.0%)</a:t>
+                      </a:r>
+                    </a:p>
+                  </a:txBody>
+                  <a:tcPr anchor="ctr" marL="91440" marR="36576" marT="54864" marB="54864">
+                    <a:noFill/>
+                  </a:tcPr>
+                </a:tc>
+                <a:tc>
+                  <a:txBody>
+                    <a:bodyPr wrap="square"/>
+                    <a:lstStyle/>
+                    <a:p>
+                      <a:r>
+                        <a:rPr sz="1100" b="0">
+                          <a:solidFill>
+                            <a:srgbClr val="5B6A72"/>
+                          </a:solidFill>
+                          <a:latin typeface="Calibri"/>
+                        </a:rPr>
+                        <a:t>Server Actions, queries, guards, Supabase clients</a:t>
+                      </a:r>
+                    </a:p>
+                  </a:txBody>
+                  <a:tcPr anchor="ctr" marL="54864" marR="36576" marT="54864" marB="54864">
+                    <a:noFill/>
+                  </a:tcPr>
+                </a:tc>
+              </a:tr>
+              <a:tr h="640080">
+                <a:tc>
+                  <a:txBody>
+                    <a:bodyPr wrap="square"/>
+                    <a:lstStyle/>
+                    <a:p>
+                      <a:r>
+                        <a:rPr sz="1100" b="0">
+                          <a:solidFill>
+                            <a:srgbClr val="11242B"/>
+                          </a:solidFill>
+                          <a:latin typeface="Calibri"/>
+                        </a:rPr>
+                        <a:t/>
+                      </a:r>
+                    </a:p>
+                  </a:txBody>
+                  <a:tcPr anchor="ctr" marL="18288" marR="18288" marT="54864" marB="54864">
+                    <a:solidFill>
+                      <a:srgbClr val="C2A05B"/>
+                    </a:solidFill>
+                  </a:tcPr>
+                </a:tc>
+                <a:tc>
+                  <a:txBody>
+                    <a:bodyPr wrap="square"/>
+                    <a:lstStyle/>
+                    <a:p>
+                      <a:r>
+                        <a:rPr sz="1100" b="1">
+                          <a:solidFill>
+                            <a:srgbClr val="11242B"/>
+                          </a:solidFill>
+                          <a:latin typeface="Calibri"/>
+                        </a:rPr>
+                        <a:t>SQL  3,971 (16.4%)</a:t>
+                      </a:r>
+                    </a:p>
+                  </a:txBody>
+                  <a:tcPr anchor="ctr" marL="91440" marR="36576" marT="54864" marB="54864">
+                    <a:noFill/>
+                  </a:tcPr>
+                </a:tc>
+                <a:tc>
+                  <a:txBody>
+                    <a:bodyPr wrap="square"/>
+                    <a:lstStyle/>
+                    <a:p>
+                      <a:r>
+                        <a:rPr sz="1100" b="0">
+                          <a:solidFill>
+                            <a:srgbClr val="5B6A72"/>
+                          </a:solidFill>
+                          <a:latin typeface="Calibri"/>
+                        </a:rPr>
+                        <a:t>16 migrations, ~62 RLS policies, ~40 RPCs</a:t>
+                      </a:r>
+                    </a:p>
+                  </a:txBody>
+                  <a:tcPr anchor="ctr" marL="54864" marR="36576" marT="54864" marB="54864">
+                    <a:noFill/>
+                  </a:tcPr>
+                </a:tc>
+              </a:tr>
+              <a:tr h="640080">
+                <a:tc>
+                  <a:txBody>
+                    <a:bodyPr wrap="square"/>
+                    <a:lstStyle/>
+                    <a:p>
+                      <a:r>
+                        <a:rPr sz="1100" b="0">
+                          <a:solidFill>
+                            <a:srgbClr val="11242B"/>
+                          </a:solidFill>
+                          <a:latin typeface="Calibri"/>
+                        </a:rPr>
+                        <a:t/>
+                      </a:r>
+                    </a:p>
+                  </a:txBody>
+                  <a:tcPr anchor="ctr" marL="18288" marR="18288" marT="54864" marB="54864">
+                    <a:solidFill>
+                      <a:srgbClr val="58B6C9"/>
+                    </a:solidFill>
+                  </a:tcPr>
+                </a:tc>
+                <a:tc>
+                  <a:txBody>
+                    <a:bodyPr wrap="square"/>
+                    <a:lstStyle/>
+                    <a:p>
+                      <a:r>
+                        <a:rPr sz="1100" b="1">
+                          <a:solidFill>
+                            <a:srgbClr val="11242B"/>
+                          </a:solidFill>
+                          <a:latin typeface="Calibri"/>
+                        </a:rPr>
+                        <a:t>JSON  1,068 (4.4%)</a:t>
+                      </a:r>
+                    </a:p>
+                  </a:txBody>
+                  <a:tcPr anchor="ctr" marL="91440" marR="36576" marT="54864" marB="54864">
+                    <a:noFill/>
+                  </a:tcPr>
+                </a:tc>
+                <a:tc>
+                  <a:txBody>
+                    <a:bodyPr wrap="square"/>
+                    <a:lstStyle/>
+                    <a:p>
+                      <a:r>
+                        <a:rPr sz="1100" b="0">
+                          <a:solidFill>
+                            <a:srgbClr val="5B6A72"/>
+                          </a:solidFill>
+                          <a:latin typeface="Calibri"/>
+                        </a:rPr>
+                        <a:t>EN/AR catalogues ~534 lines each</a:t>
+                      </a:r>
+                    </a:p>
+                  </a:txBody>
+                  <a:tcPr anchor="ctr" marL="54864" marR="36576" marT="54864" marB="54864">
+                    <a:noFill/>
+                  </a:tcPr>
+                </a:tc>
+              </a:tr>
+              <a:tr h="640080">
+                <a:tc>
+                  <a:txBody>
+                    <a:bodyPr wrap="square"/>
+                    <a:lstStyle/>
+                    <a:p>
+                      <a:r>
+                        <a:rPr sz="1100" b="0">
+                          <a:solidFill>
+                            <a:srgbClr val="11242B"/>
+                          </a:solidFill>
+                          <a:latin typeface="Calibri"/>
+                        </a:rPr>
+                        <a:t/>
+                      </a:r>
+                    </a:p>
+                  </a:txBody>
+                  <a:tcPr anchor="ctr" marL="18288" marR="18288" marT="54864" marB="54864">
+                    <a:solidFill>
+                      <a:srgbClr val="8BA0A6"/>
+                    </a:solidFill>
+                  </a:tcPr>
+                </a:tc>
+                <a:tc>
+                  <a:txBody>
+                    <a:bodyPr wrap="square"/>
+                    <a:lstStyle/>
+                    <a:p>
+                      <a:r>
+                        <a:rPr sz="1100" b="1">
+                          <a:solidFill>
+                            <a:srgbClr val="11242B"/>
+                          </a:solidFill>
+                          <a:latin typeface="Calibri"/>
+                        </a:rPr>
+                        <a:t>JS  554 (2.3%)</a:t>
+                      </a:r>
+                    </a:p>
+                  </a:txBody>
+                  <a:tcPr anchor="ctr" marL="91440" marR="36576" marT="54864" marB="54864">
+                    <a:noFill/>
+                  </a:tcPr>
+                </a:tc>
+                <a:tc>
+                  <a:txBody>
+                    <a:bodyPr wrap="square"/>
+                    <a:lstStyle/>
+                    <a:p>
+                      <a:r>
+                        <a:rPr sz="1100" b="0">
+                          <a:solidFill>
+                            <a:srgbClr val="5B6A72"/>
+                          </a:solidFill>
+                          <a:latin typeface="Calibri"/>
+                        </a:rPr>
+                        <a:t>admin scripts, e2e, configs</a:t>
+                      </a:r>
+                    </a:p>
+                  </a:txBody>
+                  <a:tcPr anchor="ctr" marL="54864" marR="36576" marT="54864" marB="54864">
+                    <a:noFill/>
+                  </a:tcPr>
+                </a:tc>
+              </a:tr>
+              <a:tr h="640080">
+                <a:tc>
+                  <a:txBody>
+                    <a:bodyPr wrap="square"/>
+                    <a:lstStyle/>
+                    <a:p>
+                      <a:r>
+                        <a:rPr sz="1100" b="0">
+                          <a:solidFill>
+                            <a:srgbClr val="11242B"/>
+                          </a:solidFill>
+                          <a:latin typeface="Calibri"/>
+                        </a:rPr>
+                        <a:t/>
+                      </a:r>
+                    </a:p>
+                  </a:txBody>
+                  <a:tcPr anchor="ctr" marL="18288" marR="18288" marT="54864" marB="54864">
+                    <a:solidFill>
+                      <a:srgbClr val="0D3444"/>
+                    </a:solidFill>
+                  </a:tcPr>
+                </a:tc>
+                <a:tc>
+                  <a:txBody>
+                    <a:bodyPr wrap="square"/>
+                    <a:lstStyle/>
+                    <a:p>
+                      <a:r>
+                        <a:rPr sz="1100" b="1">
+                          <a:solidFill>
+                            <a:srgbClr val="11242B"/>
+                          </a:solidFill>
+                          <a:latin typeface="Calibri"/>
+                        </a:rPr>
+                        <a:t>CSS  276 (1.1%)</a:t>
+                      </a:r>
+                    </a:p>
+                  </a:txBody>
+                  <a:tcPr anchor="ctr" marL="91440" marR="36576" marT="54864" marB="54864">
+                    <a:noFill/>
+                  </a:tcPr>
+                </a:tc>
+                <a:tc>
+                  <a:txBody>
+                    <a:bodyPr wrap="square"/>
+                    <a:lstStyle/>
+                    <a:p>
+                      <a:r>
+                        <a:rPr sz="1100" b="0">
+                          <a:solidFill>
+                            <a:srgbClr val="5B6A72"/>
+                          </a:solidFill>
+                          <a:latin typeface="Calibri"/>
+                        </a:rPr>
+                        <a:t>tokens + Tailwind v4 theme (globals.css)</a:t>
+                      </a:r>
+                    </a:p>
+                  </a:txBody>
+                  <a:tcPr anchor="ctr" marL="54864" marR="36576" marT="54864" marB="54864">
+                    <a:noFill/>
+                  </a:tcPr>
+                </a:tc>
+              </a:tr>
+            </a:tbl>
+          </a:graphicData>
+        </a:graphic>
+      </p:graphicFrame>
     </p:spTree>
   </p:cSld>
   <p:clrMapOvr>

</xml_diff>